<commit_message>
Frontend round 2, 22/22 E2E on the live stack, refreshed evidence, deck and Word docs
Frontend (Frontend Developer agent): honest framing (realistic 90.2% headline, 99.0% ceiling),
business-case table from /api/roi, new Stock & routes page, delay-alert forecast fields,
per-result "API offline" labels, demo-token header, offline snapshot regenerated from
findings.json. Integration: 22/22 Playwright tests pass against the production build and live
API (two tests updated for the new intake rule and an exact region match). Evidence refreshed:
backend 106 tests / 93% coverage, frontend 15 tests. Screenshots, pitch deck and Word downloads
rebuilt with the corrected numbers.

Co-Authored-By: Claude Opus 5.5 <noreply@anthropic.com>
Claude-Session: https://claude.ai/code/session_018mJx5VLNFyHg3anBqqcAy7
</commit_message>
<xml_diff>
--- a/deck/DeliveryLens-pitch.pptx
+++ b/deck/DeliveryLens-pitch.pptx
@@ -126,52 +126,52 @@
   <p:extLst>
     <p:ext uri="{521415D9-36F7-43E2-AB2F-B90AF26B5E84}">
       <p14:sectionLst xmlns:p14="http://schemas.microsoft.com/office/powerpoint/2010/main">
-        <p14:section name="Opening" id="{a1d01c93-63ab-aba7-15a5-16c85d0dce3a}">
+        <p14:section name="Opening" id="{682cd84a-f6e9-19ff-8886-14ab8094c19e}">
           <p14:sldIdLst>
             <p14:sldId id="256"/>
           </p14:sldIdLst>
         </p14:section>
-        <p14:section name="1 · Discovery insights &amp; the key problem" id="{69a7da86-1fe5-fdc1-cbda-2081ec8f5048}">
+        <p14:section name="1 · Discovery insights &amp; the key problem" id="{8ba11b07-7fe2-91c3-2dd5-23ccb811a46f}">
           <p14:sldIdLst>
             <p14:sldId id="257"/>
             <p14:sldId id="258"/>
             <p14:sldId id="259"/>
           </p14:sldIdLst>
         </p14:section>
-        <p14:section name="2 · Solution approach &amp; architecture" id="{b1a171fc-e4c6-3fd6-d876-8ff3dda503d3}">
+        <p14:section name="2 · Solution approach &amp; architecture" id="{75c35ae6-e0a7-6387-c6d0-440c032afe1e}">
           <p14:sldIdLst>
             <p14:sldId id="260"/>
             <p14:sldId id="261"/>
             <p14:sldId id="262"/>
           </p14:sldIdLst>
         </p14:section>
-        <p14:section name="3 · AI agents used" id="{469b47ff-48e8-56c1-f343-1ca036035a8d}">
+        <p14:section name="3 · AI agents used" id="{1c9445f7-6dc2-ba68-02b6-3dd07a292337}">
           <p14:sldIdLst>
             <p14:sldId id="263"/>
             <p14:sldId id="264"/>
             <p14:sldId id="265"/>
           </p14:sldIdLst>
         </p14:section>
-        <p14:section name="4 · Quality, validation &amp; security" id="{c7c81754-33af-a0af-40bc-25f4888ed734}">
+        <p14:section name="4 · Quality, validation &amp; security" id="{f188e63c-c86a-28fb-ff38-328075cac695}">
           <p14:sldIdLst>
             <p14:sldId id="266"/>
             <p14:sldId id="267"/>
           </p14:sldIdLst>
         </p14:section>
-        <p14:section name="5 · Metrics &amp; business impact" id="{4f9333ca-d5ab-1228-c3ed-a78f8c1bc830}">
+        <p14:section name="5 · Metrics &amp; business impact" id="{66a7be34-d419-9085-014c-368f1f17bfaf}">
           <p14:sldIdLst>
             <p14:sldId id="268"/>
             <p14:sldId id="269"/>
             <p14:sldId id="270"/>
           </p14:sldIdLst>
         </p14:section>
-        <p14:section name="6 · Future scope" id="{929520bc-5be6-20c7-1f1f-5f54925e9df7}">
+        <p14:section name="6 · Future scope" id="{6672af72-4a61-8f0a-3bb4-d7840a4c71ea}">
           <p14:sldIdLst>
             <p14:sldId id="271"/>
             <p14:sldId id="272"/>
           </p14:sldIdLst>
         </p14:section>
-        <p14:section name="7 · Live demo" id="{8dbbe50f-ff1d-2ba1-f3b6-1aee64741927}">
+        <p14:section name="7 · Live demo" id="{3f3e7e60-6c55-c27b-4262-40059d74c4d3}">
           <p14:sldIdLst>
             <p14:sldId id="273"/>
             <p14:sldId id="274"/>
@@ -280,10 +280,10 @@
                 <c:ptCount val="5"/>
                 <c:lvl>
                   <c:pt idx="0">
-                    <c:v>Address incomplete when the order came in</c:v>
+                    <c:v>Weak carrier on that lane (D everywhere, E to West, F to Northeast/Southeast)</c:v>
                   </c:pt>
                   <c:pt idx="1">
-                    <c:v>Carrier is weak in that destination region</c:v>
+                    <c:v>Address incomplete when the order came in</c:v>
                   </c:pt>
                   <c:pt idx="2">
                     <c:v>Same-day order received after the 08:00 pick-list cutoff</c:v>
@@ -305,19 +305,19 @@
                 <c:formatCode>General</c:formatCode>
                 <c:ptCount val="5"/>
                 <c:pt idx="0">
-                  <c:v>6.8</c:v>
+                  <c:v>7.7</c:v>
                 </c:pt>
                 <c:pt idx="1">
-                  <c:v>5.7</c:v>
+                  <c:v>6.9</c:v>
                 </c:pt>
                 <c:pt idx="2">
-                  <c:v>5.3</c:v>
+                  <c:v>5.4</c:v>
                 </c:pt>
                 <c:pt idx="3">
-                  <c:v>4.8</c:v>
+                  <c:v>4.9</c:v>
                 </c:pt>
                 <c:pt idx="4">
-                  <c:v>3</c:v>
+                  <c:v>3.1</c:v>
                 </c:pt>
               </c:numCache>
             </c:numRef>
@@ -587,11 +587,22 @@
               <a:effectLst/>
             </c:spPr>
           </c:dPt>
+          <c:dPt>
+            <c:idx val="4"/>
+            <c:invertIfNegative val="0"/>
+            <c:bubble3D val="0"/>
+            <c:spPr>
+              <a:solidFill>
+                <a:srgbClr val="15212B"/>
+              </a:solidFill>
+              <a:effectLst/>
+            </c:spPr>
+          </c:dPt>
           <c:cat>
             <c:multiLvlStrRef>
-              <c:f>Sheet1!$A$2:$A$5</c:f>
+              <c:f>Sheet1!$A$2:$A$6</c:f>
               <c:multiLvlStrCache>
-                <c:ptCount val="4"/>
+                <c:ptCount val="5"/>
                 <c:lvl>
                   <c:pt idx="0">
                     <c:v>Today</c:v>
@@ -600,10 +611,13 @@
                     <c:v>Routing vendor only</c:v>
                   </c:pt>
                   <c:pt idx="2">
-                    <c:v>Our 3 process fixes</c:v>
+                    <c:v>3 process fixes</c:v>
                   </c:pt>
                   <c:pt idx="3">
-                    <c:v>All 5 fixes</c:v>
+                    <c:v>All 5, realistic</c:v>
+                  </c:pt>
+                  <c:pt idx="4">
+                    <c:v>All 5, ceiling</c:v>
                   </c:pt>
                 </c:lvl>
               </c:multiLvlStrCache>
@@ -611,21 +625,24 @@
           </c:cat>
           <c:val>
             <c:numRef>
-              <c:f>Sheet1!$B$2:$B$5</c:f>
+              <c:f>Sheet1!$B$2:$B$6</c:f>
               <c:numCache>
                 <c:formatCode>General</c:formatCode>
-                <c:ptCount val="4"/>
+                <c:ptCount val="5"/>
                 <c:pt idx="0">
                   <c:v>71</c:v>
                 </c:pt>
                 <c:pt idx="1">
-                  <c:v>78.6</c:v>
+                  <c:v>80.2</c:v>
                 </c:pt>
                 <c:pt idx="2">
                   <c:v>86.7</c:v>
                 </c:pt>
                 <c:pt idx="3">
-                  <c:v>96.6</c:v>
+                  <c:v>90.2</c:v>
+                </c:pt>
+                <c:pt idx="4">
+                  <c:v>99</c:v>
                 </c:pt>
               </c:numCache>
             </c:numRef>
@@ -1613,7 +1630,7 @@
           <a:p>
             <a:r>
               <a:rPr lang="en-US" dirty="0"/>
-              <a:t>Money = 6 months of penalties and redelivery costs x2, for late deliveries that become on time. Revenue protected (9 clients, $14.2M) comes on top.</a:t>
+              <a:t>Ceiling 99.0% if every cause is fully removed. Each fix must work about 84% of the time to reach 94%. Money = 6 months x2; costs are our estimates. Revenue at risk ($14.2M) comes on top.</a:t>
             </a:r>
             <a:endParaRPr lang="en-US" dirty="0"/>
           </a:p>
@@ -2317,7 +2334,7 @@
           <a:p>
             <a:r>
               <a:rPr lang="en-US" dirty="0"/>
-              <a:t>Discovery: we asked 12 data-driven questions through the L&amp;D log (docs/working). Main reframe: lateness starts before the truck.</a:t>
+              <a:t>Discovery: we asked 12 data-driven questions through the L&amp;D log (docs/working); answers due Mon 26 Oct. Main reframe: most lateness starts before the truck, and the carrier problem is lane choice, not routing.</a:t>
             </a:r>
             <a:endParaRPr lang="en-US" dirty="0"/>
           </a:p>
@@ -2405,7 +2422,7 @@
           <a:p>
             <a:r>
               <a:rPr lang="en-US" dirty="0"/>
-              <a:t>Fair share = Shapley split, so overlapping causes are not double counted. The five sum from 71.0% to 96.6%.</a:t>
+              <a:t>Fair share = Shapley split, so overlapping causes are not double counted. Weak lanes were picked with a fixed rule on Apr-Jun and confirmed on Jul-Sep.</a:t>
             </a:r>
             <a:endParaRPr lang="en-US" dirty="0"/>
           </a:p>
@@ -4304,7 +4321,7 @@
                   <a:schemeClr val="accent1"/>
                 </a:solidFill>
               </a:rPr>
-              <a:t>48</a:t>
+              <a:t>106</a:t>
             </a:r>
             <a:endParaRPr lang="en-US" sz="3600" dirty="0"/>
           </a:p>
@@ -4340,7 +4357,7 @@
                   <a:schemeClr val="accent3"/>
                 </a:solidFill>
               </a:rPr>
-              <a:t>Backend tests (numbers match the analysis exactly)</a:t>
+              <a:t>Backend tests on SQLite + PostgreSQL (93% coverage)</a:t>
             </a:r>
             <a:endParaRPr lang="en-US" sz="1400" dirty="0"/>
           </a:p>
@@ -4403,7 +4420,7 @@
                   <a:schemeClr val="accent1"/>
                 </a:solidFill>
               </a:rPr>
-              <a:t>12</a:t>
+              <a:t>22</a:t>
             </a:r>
             <a:endParaRPr lang="en-US" sz="3600" dirty="0"/>
           </a:p>
@@ -4439,7 +4456,7 @@
                   <a:schemeClr val="accent3"/>
                 </a:solidFill>
               </a:rPr>
-              <a:t>Frontend tests + browser E2E on every screen</a:t>
+              <a:t>Browser end-to-end tests on every screen and agent</a:t>
             </a:r>
             <a:endParaRPr lang="en-US" sz="1400" dirty="0"/>
           </a:p>
@@ -4502,7 +4519,7 @@
                   <a:schemeClr val="accent1"/>
                 </a:solidFill>
               </a:rPr>
-              <a:t>96.3%</a:t>
+              <a:t>98.9%</a:t>
             </a:r>
             <a:endParaRPr lang="en-US" sz="3600" dirty="0"/>
           </a:p>
@@ -4538,7 +4555,7 @@
                   <a:schemeClr val="accent3"/>
                 </a:solidFill>
               </a:rPr>
-              <a:t>Out-of-time check (Jul–Sep)</a:t>
+              <a:t>Unseen-months check (Jul–Sep, no problem)</a:t>
             </a:r>
             <a:endParaRPr lang="en-US" sz="1400" dirty="0"/>
           </a:p>
@@ -4677,7 +4694,7 @@
                   <a:schemeClr val="tx1"/>
                 </a:solidFill>
               </a:rPr>
-              <a:t>CI on every push: tests, security scan, and a re-run of the analysis that must reproduce 71.0% / 96.6%</a:t>
+              <a:t>CI on every push: backend, frontend and Postgres tests, security scans, and a re-run of the analysis that must reproduce the headline numbers</a:t>
             </a:r>
             <a:endParaRPr lang="en-US" sz="1600" dirty="0"/>
           </a:p>
@@ -4967,7 +4984,7 @@
                   <a:schemeClr val="tx1"/>
                 </a:solidFill>
               </a:rPr>
-              <a:t>Routing alone: 78.6%. Fixing the causes: 96.6%</a:t>
+              <a:t>Routing alone: 80.2%. Realistic plan: 90.2%</a:t>
             </a:r>
             <a:endParaRPr lang="en-US" sz="3200" dirty="0"/>
           </a:p>
@@ -5046,7 +5063,7 @@
                   <a:schemeClr val="accent1"/>
                 </a:solidFill>
               </a:rPr>
-              <a:t>$2.39M / yr</a:t>
+              <a:t>$1.44M / yr</a:t>
             </a:r>
             <a:endParaRPr lang="en-US" sz="3600" dirty="0"/>
           </a:p>
@@ -5082,7 +5099,7 @@
                   <a:schemeClr val="accent3"/>
                 </a:solidFill>
               </a:rPr>
-              <a:t>Penalties + redelivery avoided if all 5 are fixed</a:t>
+              <a:t>Net benefit, realistic plan (cost $359K/yr est.)</a:t>
             </a:r>
             <a:endParaRPr lang="en-US" sz="1400" dirty="0"/>
           </a:p>
@@ -5145,7 +5162,7 @@
                   <a:schemeClr val="accent1"/>
                 </a:solidFill>
               </a:rPr>
-              <a:t>$1.52M / yr</a:t>
+              <a:t>$806K / yr</a:t>
             </a:r>
             <a:endParaRPr lang="en-US" sz="3600" dirty="0"/>
           </a:p>
@@ -5181,7 +5198,7 @@
                   <a:schemeClr val="accent3"/>
                 </a:solidFill>
               </a:rPr>
-              <a:t>From the 3 process fixes alone (no new software)</a:t>
+              <a:t>Same plan, counting penalties only (cautious)</a:t>
             </a:r>
             <a:endParaRPr lang="en-US" sz="1400" dirty="0"/>
           </a:p>
@@ -5241,10 +5258,10 @@
             <a:r>
               <a:rPr lang="en-US" sz="3600" b="1" dirty="0">
                 <a:solidFill>
-                  <a:schemeClr val="accent3"/>
-                </a:solidFill>
-              </a:rPr>
-              <a:t>$0.70M / yr</a:t>
+                  <a:schemeClr val="accent2"/>
+                </a:solidFill>
+              </a:rPr>
+              <a:t>−$160K / yr</a:t>
             </a:r>
             <a:endParaRPr lang="en-US" sz="3600" dirty="0"/>
           </a:p>
@@ -5280,7 +5297,7 @@
                   <a:schemeClr val="accent3"/>
                 </a:solidFill>
               </a:rPr>
-              <a:t>From routing-related fixes (vs $680K budget)</a:t>
+              <a:t>Routing vendor, penalties only, after the $680K</a:t>
             </a:r>
             <a:endParaRPr lang="en-US" sz="1400" dirty="0"/>
           </a:p>
@@ -5557,7 +5574,7 @@
                   <a:schemeClr val="tx1"/>
                 </a:solidFill>
               </a:rPr>
-              <a:t>Address check at intake, same-day promise rule or second pick wave, monthly stock rebalancing → about 87%</a:t>
+              <a:t>Address check at intake, same-day promise rule or second pick wave, monthly stock rebalancing</a:t>
             </a:r>
             <a:endParaRPr lang="en-US" sz="1500" dirty="0"/>
           </a:p>
@@ -5690,7 +5707,7 @@
                   <a:schemeClr val="tx1"/>
                 </a:solidFill>
               </a:rPr>
-              <a:t>Choose carriers by region</a:t>
+              <a:t>Choose carriers by lane</a:t>
             </a:r>
             <a:endParaRPr lang="en-US" sz="1800" dirty="0"/>
           </a:p>
@@ -5726,7 +5743,7 @@
                   <a:schemeClr val="tx1"/>
                 </a:solidFill>
               </a:rPr>
-              <a:t>Stop the 5 weak carrier–region pairs; no new software → most of the remaining gap</a:t>
+              <a:t>Stop Carrier D and the weak E/F lanes; no new software, ~$84K/yr higher rates</a:t>
             </a:r>
             <a:endParaRPr lang="en-US" sz="1500" dirty="0"/>
           </a:p>
@@ -5895,7 +5912,7 @@
                   <a:schemeClr val="tx1"/>
                 </a:solidFill>
               </a:rPr>
-              <a:t>Only on lanes with high route deviation; measure before scaling → last ~3 points</a:t>
+              <a:t>Only on lanes with high route deviation; measure before scaling (~3 points at stake)</a:t>
             </a:r>
             <a:endParaRPr lang="en-US" sz="1500" dirty="0"/>
           </a:p>
@@ -5958,7 +5975,7 @@
                   <a:srgbClr val="0E6B63"/>
                 </a:solidFill>
               </a:rPr>
-              <a:t>Target: above 94% on time. </a:t>
+              <a:t>Realistic: 90.2% on time, $1.44M a year net. </a:t>
             </a:r>
             <a:pPr indent="0" marL="0">
               <a:buNone/>
@@ -5969,7 +5986,7 @@
                   <a:schemeClr val="tx1"/>
                 </a:solidFill>
               </a:rPr>
-              <a:t>Protects the $14.2M at risk and avoids ~$2.4M a year in penalties and redeliveries, while spending less than the $680K routing contract on the smallest cause.</a:t>
+              <a:t>94%+ if each fix works about 84% of the time. Start proactive delay alerts for the 9 at-risk clients ($14.2M) on day 1.</a:t>
             </a:r>
             <a:endParaRPr lang="en-US" sz="1700" dirty="0"/>
           </a:p>
@@ -6653,7 +6670,7 @@
                   <a:schemeClr val="tx1"/>
                 </a:solidFill>
               </a:rPr>
-              <a:t>Overview: 71% today vs 96.6% possible</a:t>
+              <a:t>Overview: 71% today, 90% realistic, 99% ceiling</a:t>
             </a:r>
             <a:endParaRPr lang="en-US" sz="1600" dirty="0"/>
           </a:p>
@@ -6689,7 +6706,7 @@
                   <a:schemeClr val="tx1"/>
                 </a:solidFill>
               </a:rPr>
-              <a:t>Vendor decision: routing only 78.6%</a:t>
+              <a:t>Vendor decision: routing only 80.2%, plus the business case</a:t>
             </a:r>
             <a:endParaRPr lang="en-US" sz="1600" dirty="0"/>
           </a:p>
@@ -6766,7 +6783,7 @@
         <p:spPr>
           <a:xfrm>
             <a:off x="6309360" y="1280160"/>
-            <a:ext cx="5303520" cy="4284250"/>
+            <a:ext cx="5284559" cy="4937760"/>
           </a:xfrm>
           <a:prstGeom prst="rect">
             <a:avLst/>
@@ -7062,7 +7079,7 @@
                   <a:schemeClr val="accent5"/>
                 </a:solidFill>
               </a:rPr>
-              <a:t>71% → 96.6% on time · $2.4M a year in penalties and redeliveries avoided · $14.2M of revenue protected</a:t>
+              <a:t>71% → 90.2% on time (realistic) · $1.44M a year net · $14.2M of revenue protected</a:t>
             </a:r>
             <a:endParaRPr lang="en-US" sz="2200" dirty="0"/>
           </a:p>
@@ -7784,7 +7801,7 @@
                   <a:schemeClr val="accent1"/>
                 </a:solidFill>
               </a:rPr>
-              <a:t>96.6%</a:t>
+              <a:t>99.0%</a:t>
             </a:r>
             <a:endParaRPr lang="en-US" sz="3600" dirty="0"/>
           </a:p>
@@ -7820,7 +7837,7 @@
                   <a:schemeClr val="accent3"/>
                 </a:solidFill>
               </a:rPr>
-              <a:t>On-time for deliveries with none of the 5 problems (already above 94%)</a:t>
+              <a:t>On-time for deliveries with none of the 5 problems</a:t>
             </a:r>
             <a:endParaRPr lang="en-US" sz="1400" dirty="0"/>
           </a:p>
@@ -7878,7 +7895,7 @@
                   <a:schemeClr val="tx1"/>
                 </a:solidFill>
               </a:rPr>
-              <a:t>Holds on unseen months: rules picked on Apr–Jun give 96.3% on Jul–Sep</a:t>
+              <a:t>Holds on unseen months: rules picked on Apr–Jun give 98.9% on Jul–Sep</a:t>
             </a:r>
             <a:endParaRPr lang="en-US" sz="1500" dirty="0"/>
           </a:p>
@@ -7896,7 +7913,25 @@
                   <a:schemeClr val="tx1"/>
                 </a:solidFill>
               </a:rPr>
-              <a:t>Biggest single cause: incomplete addresses, 28% of email orders</a:t>
+              <a:t>The 5 causes explain 28 of the 29 points lost</a:t>
+            </a:r>
+            <a:endParaRPr lang="en-US" sz="1500" dirty="0"/>
+          </a:p>
+          <a:p>
+            <a:pPr marL="342900" indent="-342900">
+              <a:spcAft>
+                <a:spcPts val="800"/>
+              </a:spcAft>
+              <a:buSzPct val="100000"/>
+              <a:buChar char="•"/>
+            </a:pPr>
+            <a:r>
+              <a:rPr lang="en-US" sz="1500" dirty="0">
+                <a:solidFill>
+                  <a:schemeClr val="tx1"/>
+                </a:solidFill>
+              </a:rPr>
+              <a:t>Biggest: weak carrier lanes (Carrier D everywhere); then incomplete addresses (28% of email orders)</a:t>
             </a:r>
             <a:endParaRPr lang="en-US" sz="1500" dirty="0"/>
           </a:p>
@@ -8321,7 +8356,7 @@
                             <a:srgbClr val="15212B"/>
                           </a:solidFill>
                         </a:rPr>
-                        <a:t>Incomplete address (6.8)</a:t>
+                        <a:t>Weak carrier on a lane (7.7)</a:t>
                       </a:r>
                       <a:endParaRPr lang="en-US" sz="1500" dirty="0"/>
                     </a:p>
@@ -8382,7 +8417,7 @@
                             <a:srgbClr val="15212B"/>
                           </a:solidFill>
                         </a:rPr>
-                        <a:t>Order Intake Agent reads the order, flags missing fields, drafts a request to the client</a:t>
+                        <a:t>Carrier choice by lane: Carrier D nowhere; E not to the West; F not to the Northeast/Southeast</a:t>
                       </a:r>
                       <a:endParaRPr lang="en-US" sz="1500" dirty="0"/>
                     </a:p>
@@ -8445,7 +8480,7 @@
                             <a:srgbClr val="15212B"/>
                           </a:solidFill>
                         </a:rPr>
-                        <a:t>Weak carrier on a lane (5.7)</a:t>
+                        <a:t>Incomplete address (6.9)</a:t>
                       </a:r>
                       <a:endParaRPr lang="en-US" sz="1500" dirty="0"/>
                     </a:p>
@@ -8506,7 +8541,7 @@
                             <a:srgbClr val="15212B"/>
                           </a:solidFill>
                         </a:rPr>
-                        <a:t>Carrier Advisor: best carrier per region (e.g. not F to the Southeast)</a:t>
+                        <a:t>Order Intake Agent reads the order, flags missing fields, drafts a request to the client</a:t>
                       </a:r>
                       <a:endParaRPr lang="en-US" sz="1500" dirty="0"/>
                     </a:p>
@@ -8569,7 +8604,7 @@
                             <a:srgbClr val="15212B"/>
                           </a:solidFill>
                         </a:rPr>
-                        <a:t>Same-day after 08:00 (5.3)</a:t>
+                        <a:t>Same-day after 08:00 (5.4)</a:t>
                       </a:r>
                       <a:endParaRPr lang="en-US" sz="1500" dirty="0"/>
                     </a:p>
@@ -8693,7 +8728,7 @@
                             <a:srgbClr val="15212B"/>
                           </a:solidFill>
                         </a:rPr>
-                        <a:t>Stock not at nearest warehouse (4.8)</a:t>
+                        <a:t>Stock not at nearest warehouse (4.9)</a:t>
                       </a:r>
                       <a:endParaRPr lang="en-US" sz="1500" dirty="0"/>
                     </a:p>
@@ -8817,7 +8852,7 @@
                             <a:srgbClr val="15212B"/>
                           </a:solidFill>
                         </a:rPr>
-                        <a:t>Route deviation (3.0)</a:t>
+                        <a:t>Route deviation (3.1)</a:t>
                       </a:r>
                       <a:endParaRPr lang="en-US" sz="1500" dirty="0"/>
                     </a:p>
@@ -9866,7 +9901,7 @@
         <p:spPr>
           <a:xfrm>
             <a:off x="6035040" y="1280160"/>
-            <a:ext cx="4230477" cy="4937760"/>
+            <a:ext cx="4299546" cy="4937760"/>
           </a:xfrm>
           <a:prstGeom prst="rect">
             <a:avLst/>

</xml_diff>